<commit_message>
Update deck, README, results summary, study guide and presentation notes to the 20-seed results and new baselines
Co-authored-by: Harshvardhan Choudhary <Harshvardhan-To1@users.noreply.github.com>
</commit_message>
<xml_diff>
--- a/docs/fhlm/BTP_midterm_fronthaul_load_management.pptx
+++ b/docs/fhlm/BTP_midterm_fronthaul_load_management.pptx
@@ -735,7 +735,7 @@
           <a:lstStyle/>
           <a:p>
             <a:r>
-              <a:t>Lower is better. Black is the oracle. The proposed rule, in red, is the best real controller in every scenario. Against the point-forecast controller — same model, same information — it cuts the score by 18 percent at high load and 10 percent under the held-out shift. Against the deadline-aware reactive controller by 27 and 18 percent. Against the plain proportional controller the margin is 12 percent at high load but only 3 percent under flash crowds, where it wins 3 of 5 seeds — a tie. The error bars are wide because seeds differ in when the bursts happen; the next slide compares seed by seed.</a:t>
+              <a:t>Lower is better. Black is the oracle. The proposed rule, in red, is the best real controller in every scenario. Against the point-forecast controller — same model, same information — it cuts the score by 18 percent at high load and 11 percent under the held-out shift. Against the deadline-aware reactive controller by 27 and 20 percent. Against the plain proportional controller the margin is 13 percent at high load but only 4 percent under flash crowds, where it wins 16 of 20 seeds — still significant after correction, but a small gain. The tuned MaxWeight and fixed-quantile controllers are beaten in every scenario. The error bars are wide because seeds differ in when the bursts happen; the next slide compares seed by seed.</a:t>
             </a:r>
           </a:p>
         </p:txBody>
@@ -805,7 +805,7 @@
           <a:lstStyle/>
           <a:p>
             <a:r>
-              <a:t>Each bar is how much the proposed rule lowers the score compared with one baseline, computed seed by seed on the very same traffic; the whiskers are the best and worst seed, and the text says how many of the five seeds it won. Against the point-forecast and the deadline-aware reactive controllers it wins every seed in every scenario. Against the plain proportional controller it wins every seed except under flash crowds. Green is the machine-learning ablation: the same rule fed with simple empirical quantiles instead of the trained model. The model helps a lot on normal traffic but almost not at all under the held-out shift. Purple: online calibration gives nothing and hurts under shift.</a:t>
+              <a:t>Each bar is how much the proposed rule lowers the score compared with one baseline, computed seed by seed on the very same traffic; the whiskers are the best and worst seed, and the text says how many of the 20 seeds it won. Stars mark Holm-corrected Wilcoxon significance. Against the point-forecast and the deadline-aware reactive controllers it wins every seed in every scenario. Against the plain proportional controller it wins every seed except under flash crowds. Green is the machine-learning ablation: the same rule fed with simple empirical quantiles instead of the trained model. The model helps a lot on normal traffic but almost not at all under the held-out shift. Purple: online calibration gives nothing and hurts under shift.</a:t>
             </a:r>
           </a:p>
         </p:txBody>
@@ -1085,7 +1085,7 @@
           <a:lstStyle/>
           <a:p>
             <a:r>
-              <a:t>What this is not. Part A: the compression results are quoted from the earlier report and figures; the source package is missing from the repository, so they were not re-run this term; the inversion benchmark is re-runnable. Part B: traffic is synthetic; the oracle is only interval-level; the gain over the simplest proportional controller vanishes under flash crowds and at long intervals; the learned model adds little under shift; online calibration hurt; five seeds do not allow a significance claim; the link is a budget-enforced pipe with no switch queue; decision time is Python-level, about 3 ms per 10 ms epoch.</a:t>
+              <a:t>What this is not. Part A: the compression results are quoted from the earlier report and figures; the source package is missing from the repository, so they were not re-run this term; the inversion benchmark is re-runnable. Part B: traffic is synthetic; the oracle is only interval-level; the gain over the simplest proportional controller vanishes under flash crowds and at long intervals; the learned model adds little under shift; online calibration hurt; the margin over proportional sharing also shrinks when telemetry is older than the low-latency deadline; the link is a budget-enforced pipe with no switch queue; decision time is Python-level, about 3 ms per 10 ms epoch.</a:t>
             </a:r>
           </a:p>
         </p:txBody>
@@ -2135,7 +2135,7 @@
           <a:lstStyle/>
           <a:p>
             <a:r>
-              <a:t>Five references. Static equal share ignores everything. Reactive proportional is the classic: current backlog plus a running average of demand, split proportionally, spare capacity redistributed. The deadline-aware reactive controller knows the deadlines: it uses the r-star of the last observed interval as its estimate, plus priority weights and the same water-filling split. The point-forecast controller is our ablation: identical to the proposed method except it uses the forecast median instead of the whole range. The oracle knows the real arrivals of the next interval. Every tunable knob was chosen on validation seeds, never on test seeds. The chosen safety margins were all zero: inflating a single predicted number made things worse.</a:t>
+              <a:t>Seven references. Static equal share ignores everything. Reactive proportional is the classic: current backlog plus a running average of demand, split proportionally, spare capacity redistributed. MaxWeight is the textbook queue-based controller: fill cells greedily by priority times queue length. The deadline-aware reactive controller knows the deadlines: it uses the r-star of the last observed interval as its estimate, plus priority weights and the same water-filling split. The point-forecast controller is our ablation: identical to the proposed method except it uses the forecast median instead of the whole range. The fixed-quantile controller reserves the same tuned forecast percentile for every cell, the simplest way of using the whole range. The oracle knows the real arrivals of the next interval. Every tunable knob was chosen on validation seeds, never on test seeds. The chosen safety margins were all zero: inflating a single predicted number made things worse.</a:t>
             </a:r>
           </a:p>
         </p:txBody>
@@ -6922,7 +6922,7 @@
               </a:defRPr>
             </a:pPr>
             <a:r>
-              <a:t>• Seeds: training 1000-1015 (loads 0.5-0.95) | validation 2000-2003 | test 3000-3004 — no overlap</a:t>
+              <a:t>• Seeds: training 1000-1015 (loads 0.5-0.95) | validation 2000-2003 | test 3000-3019 — no overlap</a:t>
             </a:r>
           </a:p>
           <a:p>
@@ -6937,7 +6937,7 @@
               </a:defRPr>
             </a:pPr>
             <a:r>
-              <a:t>• Each run: 20,000 slots = 10 s after a 1,000-slot warm-up; T = 20 slots; 8 controllers × 5 scenarios × 5 seeds = 200 runs</a:t>
+              <a:t>• Each run: 20,000 slots = 10 s after a 1,000-slot warm-up; T = 20 slots; 10 controllers × 5 scenarios × 20 seeds = 1000 runs</a:t>
             </a:r>
           </a:p>
           <a:p>
@@ -7063,7 +7063,7 @@
               </a:defRPr>
             </a:pPr>
             <a:r>
-              <a:t>Results: main score per scenario (5 test seeds, mean ± std)</a:t>
+              <a:t>Results: main score per scenario (20 test seeds, mean ± std)</a:t>
             </a:r>
           </a:p>
         </p:txBody>
@@ -7210,7 +7210,7 @@
               </a:defRPr>
             </a:pPr>
             <a:r>
-              <a:t>– vs point forecast (same model, median only): −18 % (high), −10 % (shift)</a:t>
+              <a:t>– vs point forecast (same model, median only): −18 % (high), −11 % (shift)</a:t>
             </a:r>
           </a:p>
           <a:p>
@@ -7225,7 +7225,7 @@
               </a:defRPr>
             </a:pPr>
             <a:r>
-              <a:t>– vs deadline-aware reactive: −27 % (high), −18 % (shift)</a:t>
+              <a:t>– vs deadline-aware reactive: −27 % (high), −20 % (shift)</a:t>
             </a:r>
           </a:p>
           <a:p>
@@ -7240,7 +7240,22 @@
               </a:defRPr>
             </a:pPr>
             <a:r>
-              <a:t>– vs reactive proportional: −12 % (high) but only −3 % under flash crowds (3/5 seeds) → a tie</a:t>
+              <a:t>– vs reactive proportional: −13 % (high) but only −4 % under flash crowds (16/20 seeds, p = 0.03) → small gain</a:t>
+            </a:r>
+          </a:p>
+          <a:p>
+            <a:pPr lvl="1">
+              <a:spcAft>
+                <a:spcPts val="600"/>
+              </a:spcAft>
+              <a:defRPr sz="1100" b="0">
+                <a:solidFill>
+                  <a:srgbClr val="222222"/>
+                </a:solidFill>
+              </a:defRPr>
+            </a:pPr>
+            <a:r>
+              <a:t>– vs MaxWeight: −31 % (high); vs fixed global quantile: −32 % (high) — per-cell levels beat one global level</a:t>
             </a:r>
           </a:p>
           <a:p>
@@ -7255,7 +7270,7 @@
               </a:defRPr>
             </a:pPr>
             <a:r>
-              <a:t>• Gap to the oracle at high load: 7.9% vs 6.9%</a:t>
+              <a:t>• Gap to the oracle at high load: 8.0% vs 6.9%</a:t>
             </a:r>
           </a:p>
           <a:p>
@@ -7498,7 +7513,7 @@
               </a:defRPr>
             </a:pPr>
             <a:r>
-              <a:t>• Wins 5/5 seeds vs point forecast and vs deadline-aware reactive in every scenario</a:t>
+              <a:t>• Wins 20/20 seeds vs point forecast, deadline-aware reactive, MaxWeight and fixed quantile in every scenario (Holm-corrected Wilcoxon p &lt; 0.01)</a:t>
             </a:r>
           </a:p>
           <a:p>
@@ -7513,7 +7528,7 @@
               </a:defRPr>
             </a:pPr>
             <a:r>
-              <a:t>• vs reactive proportional: 5/5 in four scenarios; 3/5 under flash crowds (no claim there)</a:t>
+              <a:t>• vs reactive proportional: 20/20 in four scenarios; 16/20 under flash crowds (−4 %, p = 0.03)</a:t>
             </a:r>
           </a:p>
           <a:p>
@@ -7543,7 +7558,7 @@
               </a:defRPr>
             </a:pPr>
             <a:r>
-              <a:t>– the model adds 2-51 %; least under the held-out shift (2 %) → the rule, not the model, carries most of the gain</a:t>
+              <a:t>– the model adds 2-37 %; least under the held-out shift (2 %) → the rule, not the model, carries most of the gain</a:t>
             </a:r>
           </a:p>
           <a:p>
@@ -7573,7 +7588,7 @@
               </a:defRPr>
             </a:pPr>
             <a:r>
-              <a:t>• With 5 seeds we do not claim statistical significance; we report win counts and best/worst seed</a:t>
+              <a:t>• 20 seeds: paired per-seed differences, 95 % bootstrap CI, two-sided Wilcoxon signed-rank test with Holm correction (full table in the paper)</a:t>
             </a:r>
           </a:p>
         </p:txBody>
@@ -7761,7 +7776,7 @@
         <p:spPr>
           <a:xfrm>
             <a:off x="365760" y="1005840"/>
-            <a:ext cx="11430000" cy="3912248"/>
+            <a:ext cx="11430000" cy="3905375"/>
           </a:xfrm>
           <a:prstGeom prst="rect">
             <a:avLst/>
@@ -7801,7 +7816,7 @@
               </a:defRPr>
             </a:pPr>
             <a:r>
-              <a:t>• Reactive proportional: low-latency loss 14.6% vs 3.2% for proposed — controllers that ignore deadlines sacrifice the low-latency cells</a:t>
+              <a:t>• Reactive proportional: low-latency loss 14.7% vs 3.4% for proposed — controllers that ignore deadlines sacrifice the low-latency cells</a:t>
             </a:r>
           </a:p>
           <a:p>
@@ -7816,7 +7831,7 @@
               </a:defRPr>
             </a:pPr>
             <a:r>
-              <a:t>• Among deadline-aware controllers, proposed has the lowest eMBB loss (12.3% vs 15.9% for point forecast) and the highest utilisation (72.0%)</a:t>
+              <a:t>• Among deadline-aware controllers, proposed has the lowest eMBB loss (12.3% vs 16.0% for point forecast) and the highest utilisation (72.2%)</a:t>
             </a:r>
           </a:p>
           <a:p>
@@ -8059,7 +8074,7 @@
               </a:defRPr>
             </a:pPr>
             <a:r>
-              <a:t>• Same user traffic, 3 seeds, scenario 'moderate'; only the BFP width changes</a:t>
+              <a:t>• Same user traffic, 10 seeds, scenario 'moderate'; only the BFP width changes</a:t>
             </a:r>
           </a:p>
           <a:p>
@@ -8074,7 +8089,7 @@
               </a:defRPr>
             </a:pPr>
             <a:r>
-              <a:t>– BFP-6: load 0.43 → proposed 0.04%, reactive prop. 0.13%; best = proposed</a:t>
+              <a:t>– BFP-6: load 0.44 → proposed 0.11%, reactive prop. 0.22%; best = proposed</a:t>
             </a:r>
           </a:p>
           <a:p>
@@ -8089,7 +8104,7 @@
               </a:defRPr>
             </a:pPr>
             <a:r>
-              <a:t>– BFP-9: load 0.63 → proposed 1.60%, reactive prop. 3.43%; best = proposed</a:t>
+              <a:t>– BFP-9: load 0.65 → proposed 1.96%, reactive prop. 3.90%; best = proposed</a:t>
             </a:r>
           </a:p>
           <a:p>
@@ -8104,7 +8119,7 @@
               </a:defRPr>
             </a:pPr>
             <a:r>
-              <a:t>– BFP-12: load 0.83 → proposed 10.82%, reactive prop. 10.72%; best = reactive prop.</a:t>
+              <a:t>– BFP-12: load 0.86 → proposed 12.01%, reactive prop. 11.37%; best = reactive prop.</a:t>
             </a:r>
           </a:p>
           <a:p>
@@ -8119,7 +8134,7 @@
               </a:defRPr>
             </a:pPr>
             <a:r>
-              <a:t>– BFP-14: load 0.97 → proposed 19.34%, reactive prop. 16.42%; best = reactive prop.</a:t>
+              <a:t>– BFP-14: load 0.99 → proposed 20.81%, reactive prop. 17.29%; best = reactive prop.</a:t>
             </a:r>
           </a:p>
           <a:p>
@@ -8431,7 +8446,7 @@
               </a:defRPr>
             </a:pPr>
             <a:r>
-              <a:t>• Interval sweep (scenario high, 3 seeds). Reduction by proposed vs deadline-aware reactive / vs reactive proportional / vs oracle water-fill:</a:t>
+              <a:t>• Interval sweep (scenario high, 10 seeds). Reduction by proposed vs deadline-aware reactive / vs reactive proportional / vs oracle water-fill:</a:t>
             </a:r>
           </a:p>
           <a:p>
@@ -8446,7 +8461,7 @@
               </a:defRPr>
             </a:pPr>
             <a:r>
-              <a:t>–    T=2 ms: +62% / +27% / +57%   |   T=5 ms: +52% / +37% / +13%   |   T=10 ms: +30% / +18% / -17%   |   T=20 ms: +17% / -12% / -25%</a:t>
+              <a:t>–    T=2 ms: +61% / +22% / +55%   |   T=5 ms: +50% / +32% / +16%   |   T=10 ms: +28% / +13% / -16%   |   T=20 ms: +17% / -11% / -21%</a:t>
             </a:r>
           </a:p>
           <a:p>
@@ -8725,7 +8740,7 @@
               </a:defRPr>
             </a:pPr>
             <a:r>
-              <a:t>• Not a universal win: tie with reactive proportional under flash crowds; loses to it at 20 ms intervals and at ~1.0 load; the ML model adds ≈ 2 % under the held-out shift</a:t>
+              <a:t>• Not a universal win: only ≈ 4 % better than reactive proportional under flash crowds; loses to it at 20 ms intervals, at ~0.85+ load and when telemetry is ≥ 5 ms old; the ML model adds ≈ 2 % under the held-out shift</a:t>
             </a:r>
           </a:p>
           <a:p>
@@ -8755,7 +8770,7 @@
               </a:defRPr>
             </a:pPr>
             <a:r>
-              <a:t>• 5 test seeds → we report win counts and best/worst seed, not p-values</a:t>
+              <a:t>• 20 test seeds, paired bootstrap CIs and Holm-corrected Wilcoxon tests; still one synthetic traffic generator, so no real-world claim</a:t>
             </a:r>
           </a:p>
           <a:p>
@@ -8800,7 +8815,7 @@
               </a:defRPr>
             </a:pPr>
             <a:r>
-              <a:t>• Proofs cover feasibility, equal weighted risk and backlog-first only — no stability or closed-loop optimality claims</a:t>
+              <a:t>• Proofs cover feasibility, equal weighted risk, backlog-first and bounded loss under forecast miscalibration — no stability or closed-loop optimality claims</a:t>
             </a:r>
           </a:p>
         </p:txBody>
@@ -11870,7 +11885,7 @@
               </a:defRPr>
             </a:pPr>
             <a:r>
-              <a:t>Backup: main score [%], mean ± std over 5 test seeds</a:t>
+              <a:t>Backup: main score [%], mean ± std over 20 test seeds</a:t>
             </a:r>
           </a:p>
         </p:txBody>
@@ -11955,7 +11970,7 @@
         </p:nvGraphicFramePr>
         <p:xfrm>
           <a:off x="365760" y="1051560"/>
-          <a:ext cx="11430000" cy="4206240"/>
+          <a:ext cx="11430000" cy="4389120"/>
         </p:xfrm>
         <a:graphic>
           <a:graphicData uri="http://schemas.openxmlformats.org/drawingml/2006/table">
@@ -11971,14 +11986,14 @@
                 <a:gridCol w="1905000"/>
                 <a:gridCol w="1905000"/>
               </a:tblGrid>
-              <a:tr h="467360">
+              <a:tr h="399010">
                 <a:tc>
                   <a:txBody>
                     <a:bodyPr/>
                     <a:lstStyle/>
                     <a:p>
                       <a:pPr>
-                        <a:defRPr sz="1100" b="1">
+                        <a:defRPr sz="1000" b="1">
                           <a:solidFill>
                             <a:srgbClr val="FFFFFF"/>
                           </a:solidFill>
@@ -12001,7 +12016,7 @@
                     <a:lstStyle/>
                     <a:p>
                       <a:pPr>
-                        <a:defRPr sz="1100" b="1">
+                        <a:defRPr sz="1000" b="1">
                           <a:solidFill>
                             <a:srgbClr val="FFFFFF"/>
                           </a:solidFill>
@@ -12024,7 +12039,7 @@
                     <a:lstStyle/>
                     <a:p>
                       <a:pPr>
-                        <a:defRPr sz="1100" b="1">
+                        <a:defRPr sz="1000" b="1">
                           <a:solidFill>
                             <a:srgbClr val="FFFFFF"/>
                           </a:solidFill>
@@ -12047,7 +12062,7 @@
                     <a:lstStyle/>
                     <a:p>
                       <a:pPr>
-                        <a:defRPr sz="1100" b="1">
+                        <a:defRPr sz="1000" b="1">
                           <a:solidFill>
                             <a:srgbClr val="FFFFFF"/>
                           </a:solidFill>
@@ -12070,7 +12085,7 @@
                     <a:lstStyle/>
                     <a:p>
                       <a:pPr>
-                        <a:defRPr sz="1100" b="1">
+                        <a:defRPr sz="1000" b="1">
                           <a:solidFill>
                             <a:srgbClr val="FFFFFF"/>
                           </a:solidFill>
@@ -12093,7 +12108,7 @@
                     <a:lstStyle/>
                     <a:p>
                       <a:pPr>
-                        <a:defRPr sz="1100" b="1">
+                        <a:defRPr sz="1000" b="1">
                           <a:solidFill>
                             <a:srgbClr val="FFFFFF"/>
                           </a:solidFill>
@@ -12111,14 +12126,14 @@
                   </a:tcPr>
                 </a:tc>
               </a:tr>
-              <a:tr h="467360">
+              <a:tr h="399010">
                 <a:tc>
                   <a:txBody>
                     <a:bodyPr/>
                     <a:lstStyle/>
                     <a:p>
                       <a:pPr>
-                        <a:defRPr sz="1100"/>
+                        <a:defRPr sz="1000"/>
                       </a:pPr>
                       <a:r>
                         <a:t>Static equal share</a:t>
@@ -12137,10 +12152,10 @@
                     <a:lstStyle/>
                     <a:p>
                       <a:pPr>
-                        <a:defRPr sz="1100"/>
+                        <a:defRPr sz="1000"/>
                       </a:pPr>
                       <a:r>
-                        <a:t>4.16 ± 1.15</a:t>
+                        <a:t>4.45 ± 1.05</a:t>
                       </a:r>
                     </a:p>
                   </a:txBody>
@@ -12156,10 +12171,10 @@
                     <a:lstStyle/>
                     <a:p>
                       <a:pPr>
-                        <a:defRPr sz="1100"/>
+                        <a:defRPr sz="1000"/>
                       </a:pPr>
                       <a:r>
-                        <a:t>9.38 ± 1.77</a:t>
+                        <a:t>9.65 ± 1.36</a:t>
                       </a:r>
                     </a:p>
                   </a:txBody>
@@ -12175,10 +12190,10 @@
                     <a:lstStyle/>
                     <a:p>
                       <a:pPr>
-                        <a:defRPr sz="1100"/>
+                        <a:defRPr sz="1000"/>
                       </a:pPr>
                       <a:r>
-                        <a:t>15.27 ± 2.02</a:t>
+                        <a:t>15.46 ± 1.51</a:t>
                       </a:r>
                     </a:p>
                   </a:txBody>
@@ -12194,10 +12209,10 @@
                     <a:lstStyle/>
                     <a:p>
                       <a:pPr>
-                        <a:defRPr sz="1100"/>
+                        <a:defRPr sz="1000"/>
                       </a:pPr>
                       <a:r>
-                        <a:t>19.30 ± 2.07</a:t>
+                        <a:t>19.15 ± 2.34</a:t>
                       </a:r>
                     </a:p>
                   </a:txBody>
@@ -12213,10 +12228,10 @@
                     <a:lstStyle/>
                     <a:p>
                       <a:pPr>
-                        <a:defRPr sz="1100"/>
+                        <a:defRPr sz="1000"/>
                       </a:pPr>
                       <a:r>
-                        <a:t>23.65 ± 4.18</a:t>
+                        <a:t>22.31 ± 2.99</a:t>
                       </a:r>
                     </a:p>
                   </a:txBody>
@@ -12227,14 +12242,14 @@
                   </a:tcPr>
                 </a:tc>
               </a:tr>
-              <a:tr h="467360">
+              <a:tr h="399010">
                 <a:tc>
                   <a:txBody>
                     <a:bodyPr/>
                     <a:lstStyle/>
                     <a:p>
                       <a:pPr>
-                        <a:defRPr sz="1100"/>
+                        <a:defRPr sz="1000"/>
                       </a:pPr>
                       <a:r>
                         <a:t>Reactive proportional</a:t>
@@ -12253,10 +12268,10 @@
                     <a:lstStyle/>
                     <a:p>
                       <a:pPr>
-                        <a:defRPr sz="1100"/>
+                        <a:defRPr sz="1000"/>
                       </a:pPr>
                       <a:r>
-                        <a:t>0.75 ± 0.34</a:t>
+                        <a:t>0.83 ± 0.27</a:t>
                       </a:r>
                     </a:p>
                   </a:txBody>
@@ -12272,10 +12287,10 @@
                     <a:lstStyle/>
                     <a:p>
                       <a:pPr>
-                        <a:defRPr sz="1100"/>
+                        <a:defRPr sz="1000"/>
                       </a:pPr>
                       <a:r>
-                        <a:t>3.81 ± 0.71</a:t>
+                        <a:t>4.11 ± 0.69</a:t>
                       </a:r>
                     </a:p>
                   </a:txBody>
@@ -12291,10 +12306,10 @@
                     <a:lstStyle/>
                     <a:p>
                       <a:pPr>
-                        <a:defRPr sz="1100"/>
+                        <a:defRPr sz="1000"/>
                       </a:pPr>
                       <a:r>
-                        <a:t>8.94 ± 1.15</a:t>
+                        <a:t>9.20 ± 0.99</a:t>
                       </a:r>
                     </a:p>
                   </a:txBody>
@@ -12310,10 +12325,10 @@
                     <a:lstStyle/>
                     <a:p>
                       <a:pPr>
-                        <a:defRPr sz="1100"/>
+                        <a:defRPr sz="1000"/>
                       </a:pPr>
                       <a:r>
-                        <a:t>12.25 ± 1.65</a:t>
+                        <a:t>12.27 ± 2.23</a:t>
                       </a:r>
                     </a:p>
                   </a:txBody>
@@ -12329,10 +12344,10 @@
                     <a:lstStyle/>
                     <a:p>
                       <a:pPr>
-                        <a:defRPr sz="1100"/>
+                        <a:defRPr sz="1000"/>
                       </a:pPr>
                       <a:r>
-                        <a:t>12.92 ± 3.47</a:t>
+                        <a:t>11.70 ± 2.24</a:t>
                       </a:r>
                     </a:p>
                   </a:txBody>
@@ -12343,17 +12358,17 @@
                   </a:tcPr>
                 </a:tc>
               </a:tr>
-              <a:tr h="467360">
+              <a:tr h="399010">
                 <a:tc>
                   <a:txBody>
                     <a:bodyPr/>
                     <a:lstStyle/>
                     <a:p>
                       <a:pPr>
-                        <a:defRPr sz="1100"/>
+                        <a:defRPr sz="1000"/>
                       </a:pPr>
                       <a:r>
-                        <a:t>Deadline-aware reactive</a:t>
+                        <a:t>MaxWeight (queue-weighted)</a:t>
                       </a:r>
                     </a:p>
                   </a:txBody>
@@ -12369,10 +12384,10 @@
                     <a:lstStyle/>
                     <a:p>
                       <a:pPr>
-                        <a:defRPr sz="1100"/>
+                        <a:defRPr sz="1000"/>
                       </a:pPr>
                       <a:r>
-                        <a:t>0.39 ± 0.18</a:t>
+                        <a:t>0.90 ± 0.28</a:t>
                       </a:r>
                     </a:p>
                   </a:txBody>
@@ -12388,10 +12403,10 @@
                     <a:lstStyle/>
                     <a:p>
                       <a:pPr>
-                        <a:defRPr sz="1100"/>
+                        <a:defRPr sz="1000"/>
                       </a:pPr>
                       <a:r>
-                        <a:t>4.07 ± 0.95</a:t>
+                        <a:t>4.85 ± 0.79</a:t>
                       </a:r>
                     </a:p>
                   </a:txBody>
@@ -12407,10 +12422,10 @@
                     <a:lstStyle/>
                     <a:p>
                       <a:pPr>
-                        <a:defRPr sz="1100"/>
+                        <a:defRPr sz="1000"/>
                       </a:pPr>
                       <a:r>
-                        <a:t>10.86 ± 1.84</a:t>
+                        <a:t>11.54 ± 1.27</a:t>
                       </a:r>
                     </a:p>
                   </a:txBody>
@@ -12426,10 +12441,10 @@
                     <a:lstStyle/>
                     <a:p>
                       <a:pPr>
-                        <a:defRPr sz="1100"/>
+                        <a:defRPr sz="1000"/>
                       </a:pPr>
                       <a:r>
-                        <a:t>14.70 ± 2.67</a:t>
+                        <a:t>15.24 ± 3.02</a:t>
                       </a:r>
                     </a:p>
                   </a:txBody>
@@ -12445,10 +12460,10 @@
                     <a:lstStyle/>
                     <a:p>
                       <a:pPr>
-                        <a:defRPr sz="1100"/>
+                        <a:defRPr sz="1000"/>
                       </a:pPr>
                       <a:r>
-                        <a:t>14.21 ± 4.44</a:t>
+                        <a:t>12.31 ± 2.44</a:t>
                       </a:r>
                     </a:p>
                   </a:txBody>
@@ -12459,17 +12474,17 @@
                   </a:tcPr>
                 </a:tc>
               </a:tr>
-              <a:tr h="467360">
+              <a:tr h="399010">
                 <a:tc>
                   <a:txBody>
                     <a:bodyPr/>
                     <a:lstStyle/>
                     <a:p>
                       <a:pPr>
-                        <a:defRPr sz="1100"/>
+                        <a:defRPr sz="1000"/>
                       </a:pPr>
                       <a:r>
-                        <a:t>Point forecast + water-fill</a:t>
+                        <a:t>Deadline-aware reactive</a:t>
                       </a:r>
                     </a:p>
                   </a:txBody>
@@ -12485,10 +12500,10 @@
                     <a:lstStyle/>
                     <a:p>
                       <a:pPr>
-                        <a:defRPr sz="1100"/>
+                        <a:defRPr sz="1000"/>
                       </a:pPr>
                       <a:r>
-                        <a:t>0.18 ± 0.10</a:t>
+                        <a:t>0.52 ± 0.21</a:t>
                       </a:r>
                     </a:p>
                   </a:txBody>
@@ -12504,10 +12519,10 @@
                     <a:lstStyle/>
                     <a:p>
                       <a:pPr>
-                        <a:defRPr sz="1100"/>
+                        <a:defRPr sz="1000"/>
                       </a:pPr>
                       <a:r>
-                        <a:t>3.11 ± 0.87</a:t>
+                        <a:t>4.24 ± 0.78</a:t>
                       </a:r>
                     </a:p>
                   </a:txBody>
@@ -12523,10 +12538,10 @@
                     <a:lstStyle/>
                     <a:p>
                       <a:pPr>
-                        <a:defRPr sz="1100"/>
+                        <a:defRPr sz="1000"/>
                       </a:pPr>
                       <a:r>
-                        <a:t>9.63 ± 1.82</a:t>
+                        <a:t>11.03 ± 1.33</a:t>
                       </a:r>
                     </a:p>
                   </a:txBody>
@@ -12542,10 +12557,10 @@
                     <a:lstStyle/>
                     <a:p>
                       <a:pPr>
-                        <a:defRPr sz="1100"/>
+                        <a:defRPr sz="1000"/>
                       </a:pPr>
                       <a:r>
-                        <a:t>13.44 ± 2.65</a:t>
+                        <a:t>14.51 ± 3.06</a:t>
                       </a:r>
                     </a:p>
                   </a:txBody>
@@ -12561,10 +12576,10 @@
                     <a:lstStyle/>
                     <a:p>
                       <a:pPr>
-                        <a:defRPr sz="1100"/>
+                        <a:defRPr sz="1000"/>
                       </a:pPr>
                       <a:r>
-                        <a:t>12.93 ± 4.45</a:t>
+                        <a:t>12.56 ± 2.81</a:t>
                       </a:r>
                     </a:p>
                   </a:txBody>
@@ -12575,14 +12590,246 @@
                   </a:tcPr>
                 </a:tc>
               </a:tr>
-              <a:tr h="467360">
+              <a:tr h="399010">
                 <a:tc>
                   <a:txBody>
                     <a:bodyPr/>
                     <a:lstStyle/>
                     <a:p>
                       <a:pPr>
-                        <a:defRPr sz="1100"/>
+                        <a:defRPr sz="1000"/>
+                      </a:pPr>
+                      <a:r>
+                        <a:t>Point forecast + water-fill</a:t>
+                      </a:r>
+                    </a:p>
+                  </a:txBody>
+                  <a:tcPr>
+                    <a:solidFill>
+                      <a:srgbClr val="F2F4F7"/>
+                    </a:solidFill>
+                  </a:tcPr>
+                </a:tc>
+                <a:tc>
+                  <a:txBody>
+                    <a:bodyPr/>
+                    <a:lstStyle/>
+                    <a:p>
+                      <a:pPr>
+                        <a:defRPr sz="1000"/>
+                      </a:pPr>
+                      <a:r>
+                        <a:t>0.27 ± 0.17</a:t>
+                      </a:r>
+                    </a:p>
+                  </a:txBody>
+                  <a:tcPr>
+                    <a:solidFill>
+                      <a:srgbClr val="F2F4F7"/>
+                    </a:solidFill>
+                  </a:tcPr>
+                </a:tc>
+                <a:tc>
+                  <a:txBody>
+                    <a:bodyPr/>
+                    <a:lstStyle/>
+                    <a:p>
+                      <a:pPr>
+                        <a:defRPr sz="1000"/>
+                      </a:pPr>
+                      <a:r>
+                        <a:t>3.23 ± 0.73</a:t>
+                      </a:r>
+                    </a:p>
+                  </a:txBody>
+                  <a:tcPr>
+                    <a:solidFill>
+                      <a:srgbClr val="F2F4F7"/>
+                    </a:solidFill>
+                  </a:tcPr>
+                </a:tc>
+                <a:tc>
+                  <a:txBody>
+                    <a:bodyPr/>
+                    <a:lstStyle/>
+                    <a:p>
+                      <a:pPr>
+                        <a:defRPr sz="1000"/>
+                      </a:pPr>
+                      <a:r>
+                        <a:t>9.70 ± 1.34</a:t>
+                      </a:r>
+                    </a:p>
+                  </a:txBody>
+                  <a:tcPr>
+                    <a:solidFill>
+                      <a:srgbClr val="F2F4F7"/>
+                    </a:solidFill>
+                  </a:tcPr>
+                </a:tc>
+                <a:tc>
+                  <a:txBody>
+                    <a:bodyPr/>
+                    <a:lstStyle/>
+                    <a:p>
+                      <a:pPr>
+                        <a:defRPr sz="1000"/>
+                      </a:pPr>
+                      <a:r>
+                        <a:t>13.33 ± 3.09</a:t>
+                      </a:r>
+                    </a:p>
+                  </a:txBody>
+                  <a:tcPr>
+                    <a:solidFill>
+                      <a:srgbClr val="F2F4F7"/>
+                    </a:solidFill>
+                  </a:tcPr>
+                </a:tc>
+                <a:tc>
+                  <a:txBody>
+                    <a:bodyPr/>
+                    <a:lstStyle/>
+                    <a:p>
+                      <a:pPr>
+                        <a:defRPr sz="1000"/>
+                      </a:pPr>
+                      <a:r>
+                        <a:t>11.30 ± 2.81</a:t>
+                      </a:r>
+                    </a:p>
+                  </a:txBody>
+                  <a:tcPr>
+                    <a:solidFill>
+                      <a:srgbClr val="F2F4F7"/>
+                    </a:solidFill>
+                  </a:tcPr>
+                </a:tc>
+              </a:tr>
+              <a:tr h="399010">
+                <a:tc>
+                  <a:txBody>
+                    <a:bodyPr/>
+                    <a:lstStyle/>
+                    <a:p>
+                      <a:pPr>
+                        <a:defRPr sz="1000"/>
+                      </a:pPr>
+                      <a:r>
+                        <a:t>Fixed global quantile + water-fill</a:t>
+                      </a:r>
+                    </a:p>
+                  </a:txBody>
+                  <a:tcPr>
+                    <a:solidFill>
+                      <a:srgbClr val="FFFFFF"/>
+                    </a:solidFill>
+                  </a:tcPr>
+                </a:tc>
+                <a:tc>
+                  <a:txBody>
+                    <a:bodyPr/>
+                    <a:lstStyle/>
+                    <a:p>
+                      <a:pPr>
+                        <a:defRPr sz="1000"/>
+                      </a:pPr>
+                      <a:r>
+                        <a:t>0.34 ± 0.23</a:t>
+                      </a:r>
+                    </a:p>
+                  </a:txBody>
+                  <a:tcPr>
+                    <a:solidFill>
+                      <a:srgbClr val="FFFFFF"/>
+                    </a:solidFill>
+                  </a:tcPr>
+                </a:tc>
+                <a:tc>
+                  <a:txBody>
+                    <a:bodyPr/>
+                    <a:lstStyle/>
+                    <a:p>
+                      <a:pPr>
+                        <a:defRPr sz="1000"/>
+                      </a:pPr>
+                      <a:r>
+                        <a:t>4.35 ± 1.02</a:t>
+                      </a:r>
+                    </a:p>
+                  </a:txBody>
+                  <a:tcPr>
+                    <a:solidFill>
+                      <a:srgbClr val="FFFFFF"/>
+                    </a:solidFill>
+                  </a:tcPr>
+                </a:tc>
+                <a:tc>
+                  <a:txBody>
+                    <a:bodyPr/>
+                    <a:lstStyle/>
+                    <a:p>
+                      <a:pPr>
+                        <a:defRPr sz="1000"/>
+                      </a:pPr>
+                      <a:r>
+                        <a:t>11.76 ± 1.44</a:t>
+                      </a:r>
+                    </a:p>
+                  </a:txBody>
+                  <a:tcPr>
+                    <a:solidFill>
+                      <a:srgbClr val="FFFFFF"/>
+                    </a:solidFill>
+                  </a:tcPr>
+                </a:tc>
+                <a:tc>
+                  <a:txBody>
+                    <a:bodyPr/>
+                    <a:lstStyle/>
+                    <a:p>
+                      <a:pPr>
+                        <a:defRPr sz="1000"/>
+                      </a:pPr>
+                      <a:r>
+                        <a:t>15.09 ± 3.17</a:t>
+                      </a:r>
+                    </a:p>
+                  </a:txBody>
+                  <a:tcPr>
+                    <a:solidFill>
+                      <a:srgbClr val="FFFFFF"/>
+                    </a:solidFill>
+                  </a:tcPr>
+                </a:tc>
+                <a:tc>
+                  <a:txBody>
+                    <a:bodyPr/>
+                    <a:lstStyle/>
+                    <a:p>
+                      <a:pPr>
+                        <a:defRPr sz="1000"/>
+                      </a:pPr>
+                      <a:r>
+                        <a:t>12.85 ± 3.32</a:t>
+                      </a:r>
+                    </a:p>
+                  </a:txBody>
+                  <a:tcPr>
+                    <a:solidFill>
+                      <a:srgbClr val="FFFFFF"/>
+                    </a:solidFill>
+                  </a:tcPr>
+                </a:tc>
+              </a:tr>
+              <a:tr h="399010">
+                <a:tc>
+                  <a:txBody>
+                    <a:bodyPr/>
+                    <a:lstStyle/>
+                    <a:p>
+                      <a:pPr>
+                        <a:defRPr sz="1000"/>
                       </a:pPr>
                       <a:r>
                         <a:t>Proposed rule, simple quantiles (no ML)</a:t>
@@ -12601,10 +12848,10 @@
                     <a:lstStyle/>
                     <a:p>
                       <a:pPr>
-                        <a:defRPr sz="1100"/>
+                        <a:defRPr sz="1000"/>
                       </a:pPr>
                       <a:r>
-                        <a:t>0.17 ± 0.04</a:t>
+                        <a:t>0.25 ± 0.13</a:t>
                       </a:r>
                     </a:p>
                   </a:txBody>
@@ -12620,10 +12867,10 @@
                     <a:lstStyle/>
                     <a:p>
                       <a:pPr>
-                        <a:defRPr sz="1100"/>
+                        <a:defRPr sz="1000"/>
                       </a:pPr>
                       <a:r>
-                        <a:t>2.41 ± 0.56</a:t>
+                        <a:t>2.57 ± 0.64</a:t>
                       </a:r>
                     </a:p>
                   </a:txBody>
@@ -12639,10 +12886,10 @@
                     <a:lstStyle/>
                     <a:p>
                       <a:pPr>
-                        <a:defRPr sz="1100"/>
+                        <a:defRPr sz="1000"/>
                       </a:pPr>
                       <a:r>
-                        <a:t>8.60 ± 1.74</a:t>
+                        <a:t>8.72 ± 1.34</a:t>
                       </a:r>
                     </a:p>
                   </a:txBody>
@@ -12658,10 +12905,10 @@
                     <a:lstStyle/>
                     <a:p>
                       <a:pPr>
-                        <a:defRPr sz="1100"/>
+                        <a:defRPr sz="1000"/>
                       </a:pPr>
                       <a:r>
-                        <a:t>12.67 ± 2.59</a:t>
+                        <a:t>12.67 ± 3.19</a:t>
                       </a:r>
                     </a:p>
                   </a:txBody>
@@ -12677,10 +12924,10 @@
                     <a:lstStyle/>
                     <a:p>
                       <a:pPr>
-                        <a:defRPr sz="1100"/>
+                        <a:defRPr sz="1000"/>
                       </a:pPr>
                       <a:r>
-                        <a:t>11.80 ± 4.56</a:t>
+                        <a:t>10.22 ± 2.88</a:t>
                       </a:r>
                     </a:p>
                   </a:txBody>
@@ -12691,14 +12938,14 @@
                   </a:tcPr>
                 </a:tc>
               </a:tr>
-              <a:tr h="467360">
+              <a:tr h="399010">
                 <a:tc>
                   <a:txBody>
                     <a:bodyPr/>
                     <a:lstStyle/>
                     <a:p>
                       <a:pPr>
-                        <a:defRPr sz="1100"/>
+                        <a:defRPr sz="1000"/>
                       </a:pPr>
                       <a:r>
                         <a:t>Proposed (GBM quantiles + KKT rule)</a:t>
@@ -12717,10 +12964,10 @@
                     <a:lstStyle/>
                     <a:p>
                       <a:pPr>
-                        <a:defRPr sz="1100"/>
+                        <a:defRPr sz="1000"/>
                       </a:pPr>
                       <a:r>
-                        <a:t>0.08 ± 0.04</a:t>
+                        <a:t>0.15 ± 0.13</a:t>
                       </a:r>
                     </a:p>
                   </a:txBody>
@@ -12736,10 +12983,10 @@
                     <a:lstStyle/>
                     <a:p>
                       <a:pPr>
-                        <a:defRPr sz="1100"/>
+                        <a:defRPr sz="1000"/>
                       </a:pPr>
                       <a:r>
-                        <a:t>2.00 ± 0.59</a:t>
+                        <a:t>2.15 ± 0.60</a:t>
                       </a:r>
                     </a:p>
                   </a:txBody>
@@ -12755,10 +13002,10 @@
                     <a:lstStyle/>
                     <a:p>
                       <a:pPr>
-                        <a:defRPr sz="1100"/>
+                        <a:defRPr sz="1000"/>
                       </a:pPr>
                       <a:r>
-                        <a:t>7.89 ± 1.71</a:t>
+                        <a:t>8.00 ± 1.27</a:t>
                       </a:r>
                     </a:p>
                   </a:txBody>
@@ -12774,10 +13021,10 @@
                     <a:lstStyle/>
                     <a:p>
                       <a:pPr>
-                        <a:defRPr sz="1100"/>
+                        <a:defRPr sz="1000"/>
                       </a:pPr>
                       <a:r>
-                        <a:t>11.82 ± 2.56</a:t>
+                        <a:t>11.76 ± 3.08</a:t>
                       </a:r>
                     </a:p>
                   </a:txBody>
@@ -12793,10 +13040,10 @@
                     <a:lstStyle/>
                     <a:p>
                       <a:pPr>
-                        <a:defRPr sz="1100"/>
+                        <a:defRPr sz="1000"/>
                       </a:pPr>
                       <a:r>
-                        <a:t>11.59 ± 4.27</a:t>
+                        <a:t>10.04 ± 2.71</a:t>
                       </a:r>
                     </a:p>
                   </a:txBody>
@@ -12807,14 +13054,14 @@
                   </a:tcPr>
                 </a:tc>
               </a:tr>
-              <a:tr h="467360">
+              <a:tr h="399010">
                 <a:tc>
                   <a:txBody>
                     <a:bodyPr/>
                     <a:lstStyle/>
                     <a:p>
                       <a:pPr>
-                        <a:defRPr sz="1100"/>
+                        <a:defRPr sz="1000"/>
                       </a:pPr>
                       <a:r>
                         <a:t>Proposed + online calibration</a:t>
@@ -12833,10 +13080,10 @@
                     <a:lstStyle/>
                     <a:p>
                       <a:pPr>
-                        <a:defRPr sz="1100"/>
+                        <a:defRPr sz="1000"/>
                       </a:pPr>
                       <a:r>
-                        <a:t>0.09 ± 0.02</a:t>
+                        <a:t>0.17 ± 0.13</a:t>
                       </a:r>
                     </a:p>
                   </a:txBody>
@@ -12852,10 +13099,10 @@
                     <a:lstStyle/>
                     <a:p>
                       <a:pPr>
-                        <a:defRPr sz="1100"/>
+                        <a:defRPr sz="1000"/>
                       </a:pPr>
                       <a:r>
-                        <a:t>2.02 ± 0.61</a:t>
+                        <a:t>2.17 ± 0.61</a:t>
                       </a:r>
                     </a:p>
                   </a:txBody>
@@ -12871,10 +13118,10 @@
                     <a:lstStyle/>
                     <a:p>
                       <a:pPr>
-                        <a:defRPr sz="1100"/>
+                        <a:defRPr sz="1000"/>
                       </a:pPr>
                       <a:r>
-                        <a:t>8.12 ± 1.80</a:t>
+                        <a:t>8.14 ± 1.30</a:t>
                       </a:r>
                     </a:p>
                   </a:txBody>
@@ -12890,10 +13137,10 @@
                     <a:lstStyle/>
                     <a:p>
                       <a:pPr>
-                        <a:defRPr sz="1100"/>
+                        <a:defRPr sz="1000"/>
                       </a:pPr>
                       <a:r>
-                        <a:t>12.24 ± 2.62</a:t>
+                        <a:t>12.27 ± 3.26</a:t>
                       </a:r>
                     </a:p>
                   </a:txBody>
@@ -12909,10 +13156,10 @@
                     <a:lstStyle/>
                     <a:p>
                       <a:pPr>
-                        <a:defRPr sz="1100"/>
+                        <a:defRPr sz="1000"/>
                       </a:pPr>
                       <a:r>
-                        <a:t>12.95 ± 5.17</a:t>
+                        <a:t>11.12 ± 3.22</a:t>
                       </a:r>
                     </a:p>
                   </a:txBody>
@@ -12923,14 +13170,14 @@
                   </a:tcPr>
                 </a:tc>
               </a:tr>
-              <a:tr h="467360">
+              <a:tr h="399020">
                 <a:tc>
                   <a:txBody>
                     <a:bodyPr/>
                     <a:lstStyle/>
                     <a:p>
                       <a:pPr>
-                        <a:defRPr sz="1100"/>
+                        <a:defRPr sz="1000"/>
                       </a:pPr>
                       <a:r>
                         <a:t>Oracle water-fill (knows the future)</a:t>
@@ -12949,10 +13196,10 @@
                     <a:lstStyle/>
                     <a:p>
                       <a:pPr>
-                        <a:defRPr sz="1100"/>
+                        <a:defRPr sz="1000"/>
                       </a:pPr>
                       <a:r>
-                        <a:t>0.01 ± 0.01</a:t>
+                        <a:t>0.07 ± 0.10</a:t>
                       </a:r>
                     </a:p>
                   </a:txBody>
@@ -12968,10 +13215,10 @@
                     <a:lstStyle/>
                     <a:p>
                       <a:pPr>
-                        <a:defRPr sz="1100"/>
+                        <a:defRPr sz="1000"/>
                       </a:pPr>
                       <a:r>
-                        <a:t>1.56 ± 0.60</a:t>
+                        <a:t>1.62 ± 0.56</a:t>
                       </a:r>
                     </a:p>
                   </a:txBody>
@@ -12987,10 +13234,10 @@
                     <a:lstStyle/>
                     <a:p>
                       <a:pPr>
-                        <a:defRPr sz="1100"/>
+                        <a:defRPr sz="1000"/>
                       </a:pPr>
                       <a:r>
-                        <a:t>6.90 ± 1.68</a:t>
+                        <a:t>6.89 ± 1.28</a:t>
                       </a:r>
                     </a:p>
                   </a:txBody>
@@ -13006,10 +13253,10 @@
                     <a:lstStyle/>
                     <a:p>
                       <a:pPr>
-                        <a:defRPr sz="1100"/>
+                        <a:defRPr sz="1000"/>
                       </a:pPr>
                       <a:r>
-                        <a:t>10.21 ± 2.57</a:t>
+                        <a:t>10.16 ± 2.96</a:t>
                       </a:r>
                     </a:p>
                   </a:txBody>
@@ -13025,10 +13272,10 @@
                     <a:lstStyle/>
                     <a:p>
                       <a:pPr>
-                        <a:defRPr sz="1100"/>
+                        <a:defRPr sz="1000"/>
                       </a:pPr>
                       <a:r>
-                        <a:t>8.23 ± 4.14</a:t>
+                        <a:t>6.69 ± 2.60</a:t>
                       </a:r>
                     </a:p>
                   </a:txBody>
@@ -13073,7 +13320,7 @@
               </a:defRPr>
             </a:pPr>
             <a:r>
-              <a:t>Source: results/fhlm/main_runs.csv (200 runs). Seed-by-seed statistics: results/fhlm/main_paired.csv.</a:t>
+              <a:t>Source: results/fhlm/main_runs.csv (1000 runs). Seed-by-seed statistics: results/fhlm/main_paired.csv.</a:t>
             </a:r>
           </a:p>
         </p:txBody>
@@ -17587,7 +17834,7 @@
         </p:nvGraphicFramePr>
         <p:xfrm>
           <a:off x="457200" y="1051560"/>
-          <a:ext cx="11247120" cy="2377440"/>
+          <a:ext cx="11247120" cy="2926080"/>
         </p:xfrm>
         <a:graphic>
           <a:graphicData uri="http://schemas.openxmlformats.org/drawingml/2006/table">
@@ -17601,7 +17848,7 @@
                 <a:gridCol w="1828800"/>
                 <a:gridCol w="1645920"/>
               </a:tblGrid>
-              <a:tr h="396240">
+              <a:tr h="365760">
                 <a:tc>
                   <a:txBody>
                     <a:bodyPr/>
@@ -17695,7 +17942,7 @@
                   </a:tcPr>
                 </a:tc>
               </a:tr>
-              <a:tr h="396240">
+              <a:tr h="365760">
                 <a:tc>
                   <a:txBody>
                     <a:bodyPr/>
@@ -17773,7 +18020,7 @@
                   </a:tcPr>
                 </a:tc>
               </a:tr>
-              <a:tr h="396240">
+              <a:tr h="365760">
                 <a:tc>
                   <a:txBody>
                     <a:bodyPr/>
@@ -17851,7 +18098,7 @@
                   </a:tcPr>
                 </a:tc>
               </a:tr>
-              <a:tr h="396240">
+              <a:tr h="365760">
                 <a:tc>
                   <a:txBody>
                     <a:bodyPr/>
@@ -17861,7 +18108,7 @@
                         <a:defRPr sz="1100"/>
                       </a:pPr>
                       <a:r>
-                        <a:t>Deadline-aware reactive (strong)</a:t>
+                        <a:t>MaxWeight (queue-weighted)</a:t>
                       </a:r>
                     </a:p>
                   </a:txBody>
@@ -17880,7 +18127,7 @@
                         <a:defRPr sz="1100"/>
                       </a:pPr>
                       <a:r>
-                        <a:t>backlog-clearing rate + r* of the last interval; priority weights; water-fill</a:t>
+                        <a:t>greedy fill in order of priority × queue length (optional head-of-line-age urgency)</a:t>
                       </a:r>
                     </a:p>
                   </a:txBody>
@@ -17899,7 +18146,7 @@
                         <a:defRPr sz="1100"/>
                       </a:pPr>
                       <a:r>
-                        <a:t>history, deadlines, priorities</a:t>
+                        <a:t>queues, priorities</a:t>
                       </a:r>
                     </a:p>
                   </a:txBody>
@@ -17918,7 +18165,7 @@
                         <a:defRPr sz="1100"/>
                       </a:pPr>
                       <a:r>
-                        <a:t>margin, #intervals</a:t>
+                        <a:t>margin, HOL weight</a:t>
                       </a:r>
                     </a:p>
                   </a:txBody>
@@ -17929,7 +18176,7 @@
                   </a:tcPr>
                 </a:tc>
               </a:tr>
-              <a:tr h="396240">
+              <a:tr h="365760">
                 <a:tc>
                   <a:txBody>
                     <a:bodyPr/>
@@ -17939,7 +18186,7 @@
                         <a:defRPr sz="1100"/>
                       </a:pPr>
                       <a:r>
-                        <a:t>Point forecast + water-fill (ablation)</a:t>
+                        <a:t>Deadline-aware reactive (strong)</a:t>
                       </a:r>
                     </a:p>
                   </a:txBody>
@@ -17958,7 +18205,163 @@
                         <a:defRPr sz="1100"/>
                       </a:pPr>
                       <a:r>
+                        <a:t>backlog-clearing rate + r* of the last interval; priority weights; water-fill</a:t>
+                      </a:r>
+                    </a:p>
+                  </a:txBody>
+                  <a:tcPr>
+                    <a:solidFill>
+                      <a:srgbClr val="FFFFFF"/>
+                    </a:solidFill>
+                  </a:tcPr>
+                </a:tc>
+                <a:tc>
+                  <a:txBody>
+                    <a:bodyPr/>
+                    <a:lstStyle/>
+                    <a:p>
+                      <a:pPr>
+                        <a:defRPr sz="1100"/>
+                      </a:pPr>
+                      <a:r>
+                        <a:t>history, deadlines, priorities</a:t>
+                      </a:r>
+                    </a:p>
+                  </a:txBody>
+                  <a:tcPr>
+                    <a:solidFill>
+                      <a:srgbClr val="FFFFFF"/>
+                    </a:solidFill>
+                  </a:tcPr>
+                </a:tc>
+                <a:tc>
+                  <a:txBody>
+                    <a:bodyPr/>
+                    <a:lstStyle/>
+                    <a:p>
+                      <a:pPr>
+                        <a:defRPr sz="1100"/>
+                      </a:pPr>
+                      <a:r>
+                        <a:t>margin, #intervals</a:t>
+                      </a:r>
+                    </a:p>
+                  </a:txBody>
+                  <a:tcPr>
+                    <a:solidFill>
+                      <a:srgbClr val="FFFFFF"/>
+                    </a:solidFill>
+                  </a:tcPr>
+                </a:tc>
+              </a:tr>
+              <a:tr h="365760">
+                <a:tc>
+                  <a:txBody>
+                    <a:bodyPr/>
+                    <a:lstStyle/>
+                    <a:p>
+                      <a:pPr>
+                        <a:defRPr sz="1100"/>
+                      </a:pPr>
+                      <a:r>
+                        <a:t>Point forecast + water-fill (ablation)</a:t>
+                      </a:r>
+                    </a:p>
+                  </a:txBody>
+                  <a:tcPr>
+                    <a:solidFill>
+                      <a:srgbClr val="F2F4F7"/>
+                    </a:solidFill>
+                  </a:tcPr>
+                </a:tc>
+                <a:tc>
+                  <a:txBody>
+                    <a:bodyPr/>
+                    <a:lstStyle/>
+                    <a:p>
+                      <a:pPr>
+                        <a:defRPr sz="1100"/>
+                      </a:pPr>
+                      <a:r>
                         <a:t>same as above, but r* comes from the forecast MEDIAN</a:t>
+                      </a:r>
+                    </a:p>
+                  </a:txBody>
+                  <a:tcPr>
+                    <a:solidFill>
+                      <a:srgbClr val="F2F4F7"/>
+                    </a:solidFill>
+                  </a:tcPr>
+                </a:tc>
+                <a:tc>
+                  <a:txBody>
+                    <a:bodyPr/>
+                    <a:lstStyle/>
+                    <a:p>
+                      <a:pPr>
+                        <a:defRPr sz="1100"/>
+                      </a:pPr>
+                      <a:r>
+                        <a:t>+ trained model</a:t>
+                      </a:r>
+                    </a:p>
+                  </a:txBody>
+                  <a:tcPr>
+                    <a:solidFill>
+                      <a:srgbClr val="F2F4F7"/>
+                    </a:solidFill>
+                  </a:tcPr>
+                </a:tc>
+                <a:tc>
+                  <a:txBody>
+                    <a:bodyPr/>
+                    <a:lstStyle/>
+                    <a:p>
+                      <a:pPr>
+                        <a:defRPr sz="1100"/>
+                      </a:pPr>
+                      <a:r>
+                        <a:t>margin</a:t>
+                      </a:r>
+                    </a:p>
+                  </a:txBody>
+                  <a:tcPr>
+                    <a:solidFill>
+                      <a:srgbClr val="F2F4F7"/>
+                    </a:solidFill>
+                  </a:tcPr>
+                </a:tc>
+              </a:tr>
+              <a:tr h="365760">
+                <a:tc>
+                  <a:txBody>
+                    <a:bodyPr/>
+                    <a:lstStyle/>
+                    <a:p>
+                      <a:pPr>
+                        <a:defRPr sz="1100"/>
+                      </a:pPr>
+                      <a:r>
+                        <a:t>Fixed global quantile + water-fill</a:t>
+                      </a:r>
+                    </a:p>
+                  </a:txBody>
+                  <a:tcPr>
+                    <a:solidFill>
+                      <a:srgbClr val="FFFFFF"/>
+                    </a:solidFill>
+                  </a:tcPr>
+                </a:tc>
+                <a:tc>
+                  <a:txBody>
+                    <a:bodyPr/>
+                    <a:lstStyle/>
+                    <a:p>
+                      <a:pPr>
+                        <a:defRPr sz="1100"/>
+                      </a:pPr>
+                      <a:r>
+                        <a:t>same as above, but r* = one tuned forecast percentile, identical for every cell</a:t>
                       </a:r>
                     </a:p>
                   </a:txBody>
@@ -17996,7 +18399,7 @@
                         <a:defRPr sz="1100"/>
                       </a:pPr>
                       <a:r>
-                        <a:t>margin</a:t>
+                        <a:t>level</a:t>
                       </a:r>
                     </a:p>
                   </a:txBody>
@@ -18007,7 +18410,7 @@
                   </a:tcPr>
                 </a:tc>
               </a:tr>
-              <a:tr h="396240">
+              <a:tr h="365760">
                 <a:tc>
                   <a:txBody>
                     <a:bodyPr/>
@@ -18097,8 +18500,8 @@
         </p:nvSpPr>
         <p:spPr>
           <a:xfrm>
-            <a:off x="457200" y="4343400"/>
-            <a:ext cx="11247120" cy="2011680"/>
+            <a:off x="457200" y="4617720"/>
+            <a:ext cx="11247120" cy="1828800"/>
           </a:xfrm>
           <a:prstGeom prst="rect">
             <a:avLst/>

</xml_diff>

<commit_message>
Remove em dashes from paper, docs, slides and comments; regenerate deck
Co-authored-by: Harshvardhan Choudhary <Harshvardhan-To1@users.noreply.github.com>
</commit_message>
<xml_diff>
--- a/docs/fhlm/BTP_midterm_fronthaul_load_management.pptx
+++ b/docs/fhlm/BTP_midterm_fronthaul_load_management.pptx
@@ -665,7 +665,7 @@
           <a:lstStyle/>
           <a:p>
             <a:r>
-              <a:t>The traffic is synthetic: a smooth part plus heavy-tailed on-off bursts per cell, slow load changes about every second, and drifting spectral efficiency. Five scenarios differ in average load and burstiness. 'Shift' uses heavier and longer bursts than anything the model saw in training — the held-out test. Training, validation and test seeds are separate ranges. Every controller sees exactly the same traffic, seed by seed, so we can compare them pairwise. Absolute violation numbers are high because the traffic is deliberately bursty at 80 percent load; the differences between controllers are the result.</a:t>
+              <a:t>The traffic is synthetic: a smooth part plus heavy-tailed on-off bursts per cell, slow load changes about every second, and drifting spectral efficiency. Five scenarios differ in average load and burstiness. 'Shift' uses heavier and longer bursts than anything the model saw in training; the held-out test. Training, validation and test seeds are separate ranges. Every controller sees exactly the same traffic, seed by seed, so we can compare them pairwise. Absolute violation numbers are high because the traffic is deliberately bursty at 80 percent load; the differences between controllers are the result.</a:t>
             </a:r>
           </a:p>
         </p:txBody>
@@ -735,7 +735,7 @@
           <a:lstStyle/>
           <a:p>
             <a:r>
-              <a:t>Lower is better. Black is the oracle. The proposed rule, in red, is the best real controller in every scenario. Against the point-forecast controller — same model, same information — it cuts the score by 18 percent at high load and 11 percent under the held-out shift. Against the deadline-aware reactive controller by 27 and 20 percent. Against the plain proportional controller the margin is 13 percent at high load but only 4 percent under flash crowds, where it wins 16 of 20 seeds — still significant after correction, but a small gain. The tuned MaxWeight and fixed-quantile controllers are beaten in every scenario. The error bars are wide because seeds differ in when the bursts happen; the next slide compares seed by seed.</a:t>
+              <a:t>Lower is better. Black is the oracle. The proposed rule, in red, is the best real controller in every scenario. Against the point-forecast controller (same model, same information) it cuts the score by 18 percent at high load and 11 percent under the held-out shift. Against the deadline-aware reactive controller by 27 and 20 percent. Against the plain proportional controller the margin is 13 percent at high load but only 4 percent under flash crowds, where it wins 16 of 20 seeds; still significant after correction, but a small gain. The tuned MaxWeight and fixed-quantile controllers are beaten in every scenario. The error bars are wide because seeds differ in when the bursts happen; the next slide compares seed by seed.</a:t>
             </a:r>
           </a:p>
         </p:txBody>
@@ -875,7 +875,7 @@
           <a:lstStyle/>
           <a:p>
             <a:r>
-              <a:t>Left: low-latency violations; middle: eMBB; right: link utilisation. The proportional controller keeps eMBB almost clean but lets low-latency cells lose 15 percent of their bits — it does not know about deadlines. All deadline-aware controllers protect the low-latency cells and pay with eMBB. Within that group the proposed rule has the lowest eMBB loss and the highest utilisation, because it adds margin only where the forecast is uncertain instead of everywhere. Even the oracle loses 13 percent of eMBB bits here: budgets fixed for 10 ms simply cannot follow heavy bursts, which is why the control interval matters — see the ablation slide.</a:t>
+              <a:t>Left: low-latency violations; middle: eMBB; right: link utilisation. The proportional controller keeps eMBB almost clean but lets low-latency cells lose 15 percent of their bits because it does not know about deadlines. All deadline-aware controllers protect the low-latency cells and pay with eMBB. Within that group the proposed rule has the lowest eMBB loss and the highest utilisation, because it adds margin only where the forecast is uncertain instead of everywhere. Even the oracle loses 13 percent of eMBB bits here: budgets fixed for 10 ms simply cannot follow heavy bursts, which is why the control interval matters; see the ablation slide.</a:t>
             </a:r>
           </a:p>
         </p:txBody>
@@ -945,7 +945,7 @@
           <a:lstStyle/>
           <a:p>
             <a:r>
-              <a:t>This experiment connects the two parts. Same user traffic, same seeds; only the compression setting changes: 6, 9, 12 or 14 mantissa bits, which changes how many fronthaul bits each resource block costs and therefore the load on the link. At 6 bits the load is 43 percent and almost nothing is lost, whatever the allocation rule — compression alone solves it, at the price of quantisation noise, which this experiment does not model. At 9 bits, the O-RAN default, the allocation rule matters most: the proposed rule loses about half as much as the reactive controllers. At 12 bits the link is at 83 percent and the proposed rule ties with the proportional one. At 14 bits the link is essentially full and no allocation rule helps; the proposed rule is even the worst, because protecting the low-latency cells costs too many eMBB bits. Message: compression decides which regime you are in; allocation helps most in the 50 to 80 percent regime.</a:t>
+              <a:t>This experiment connects the two parts. Same user traffic, same seeds; only the compression setting changes: 6, 9, 12 or 14 mantissa bits, which changes how many fronthaul bits each resource block costs and therefore the load on the link. At 6 bits the load is 43 percent and almost nothing is lost, whatever the allocation rule; compression alone solves it, at the price of quantisation noise, which this experiment does not model. At 9 bits, the O-RAN default, the allocation rule matters most: the proposed rule loses about half as much as the reactive controllers. At 12 bits the link is at 83 percent and the proposed rule ties with the proportional one. At 14 bits the link is essentially full and no allocation rule helps; the proposed rule is even the worst, because protecting the low-latency cells costs too many eMBB bits. Message: compression decides which regime you are in; allocation helps most in the 50 to 80 percent regime.</a:t>
             </a:r>
           </a:p>
         </p:txBody>
@@ -1015,7 +1015,7 @@
           <a:lstStyle/>
           <a:p>
             <a:r>
-              <a:t>Left: the forecast quantiles are well calibrated on validation data — the 5 percent quantile is exceeded 5.6 percent of the time, the 95 percent quantile 5.1 percent — and the median error is lower than simple persistence. Right: the control-interval sweep, forecasters retrained per interval. Two honest findings. At 2 ms the proposed rule is far ahead of every reactive controller and even of the oracle water-fill, which has a perfect single-number forecast — so the allocation rule itself does real work. At 20 ms, five times the low-latency deadline, reserving the low-latency peak rate for the whole interval wastes capacity and the plain proportional controller becomes better. So the method is for control intervals up to a few times the shortest deadline; our default of 10 ms is inside that range.</a:t>
+              <a:t>Left: the forecast quantiles are well calibrated on validation data (the 5 percent quantile is exceeded 5.6 percent of the time, the 95 percent quantile 5.1 percent) and the median error is lower than simple persistence. Right: the control-interval sweep, forecasters retrained per interval. Two honest findings. At 2 ms the proposed rule is far ahead of every reactive controller and even of the oracle water-fill, which has a perfect single-number forecast, so the allocation rule itself does real work. At 20 ms, five times the low-latency deadline, reserving the low-latency peak rate for the whole interval wastes capacity and the plain proportional controller becomes better. So the method is for control intervals up to a few times the shortest deadline; our default of 10 ms is inside that range.</a:t>
             </a:r>
           </a:p>
         </p:txBody>
@@ -1295,7 +1295,7 @@
           <a:lstStyle/>
           <a:p>
             <a:r>
-              <a:t>In Open RAN the radio unit does only the lowest layer of processing and sends frequency-domain radio samples to the distributed unit. This is the 7-2x split. The data rate is large, but it depends on how many resource blocks are scheduled, so it goes up and down with traffic. Operators use that: several radio units share one Ethernet link that is smaller than their total peak — in our setup 2.4 times smaller. That works most of the time. When several cells burst at once, someone has to wait, and low-latency traffic can only wait about two milliseconds. So there are two questions: how do we make the data smaller, and how do we share the link when it is full?</a:t>
+              <a:t>In Open RAN the radio unit does only the lowest layer of processing and sends frequency-domain radio samples to the distributed unit. This is the 7-2x split. The data rate is large, but it depends on how many resource blocks are scheduled, so it goes up and down with traffic. Operators use that: several radio units share one Ethernet link that is smaller than their total peak; in our setup 2.4 times smaller. That works most of the time. When several cells burst at once, someone has to wait, and low-latency traffic can only wait about two milliseconds. So there are two questions: how do we make the data smaller, and how do we share the link when it is full?</a:t>
             </a:r>
           </a:p>
         </p:txBody>
@@ -1505,7 +1505,7 @@
           <a:lstStyle/>
           <a:p>
             <a:r>
-              <a:t>For questions. The objective is concave and separable. Its derivative in r_i is w_i times the probability that the cell needs more than r_i, minus lambda. Setting it to zero gives the inverse-CDF form. Because the forecast CDF is zero below zero, the derivative equals w_i for budgets below the backlog — backlog is always funded before uncertain demand of a lower-weight cell. The sum of budgets decreases as lambda grows, so bisection finds the single lambda at which the link is exactly full.</a:t>
+              <a:t>For questions. The objective is concave and separable. Its derivative in r_i is w_i times the probability that the cell needs more than r_i, minus lambda. Setting it to zero gives the inverse-CDF form. Because the forecast CDF is zero below zero, the derivative equals w_i for budgets below the backlog: backlog is always funded before uncertain demand of a lower-weight cell. The sum of budgets decreases as lambda grows, so bisection finds the single lambda at which the link is exactly full.</a:t>
             </a:r>
           </a:p>
         </p:txBody>
@@ -1925,7 +1925,7 @@
           <a:lstStyle/>
           <a:p>
             <a:r>
-              <a:t>Now the sharing problem. Time runs in slots of half a millisecond. Each cell has a queue in the processing unit. User bits are turned into resource blocks using the cell's spectral efficiency, and each resource block costs a fixed number of fronthaul bits — so fronthaul load is not the same as user traffic. A bit that waits in the queue longer than its class deadline is thrown away and counted as a violation. Every 20 slots, that is 10 milliseconds, the controller gives each cell a budget in bits per slot. The budgets must add up to the link capacity and are held for the whole interval. The controller sees the state with a 2-slot delay and never sees the future. Why decide in advance? Because the budget is a reservation that is held for 10 ms and telemetry is late; the next interval's traffic is unknown when the decision is made.</a:t>
+              <a:t>Now the sharing problem. Time runs in slots of half a millisecond. Each cell has a queue in the processing unit. User bits are turned into resource blocks using the cell's spectral efficiency, and each resource block costs a fixed number of fronthaul bits, so fronthaul load is not the same as user traffic. A bit that waits in the queue longer than its class deadline is thrown away and counted as a violation. Every 20 slots, that is 10 milliseconds, the controller gives each cell a budget in bits per slot. The budgets must add up to the link capacity and are held for the whole interval. The controller sees the state with a 2-slot delay and never sees the future. Why decide in advance? Because the budget is a reservation that is held for 10 ms and telemetry is late; the next interval's traffic is unknown when the decision is made.</a:t>
             </a:r>
           </a:p>
         </p:txBody>
@@ -1995,7 +1995,7 @@
           <a:lstStyle/>
           <a:p>
             <a:r>
-              <a:t>Three groups of work. First, the standards and surveys that define the fronthaul model. Second, work that forecasts traffic and then plans capacity — mostly with neural networks and a single predicted number, with uncertainty handled by a fixed safety margin if at all. Third, work on forecasts with uncertainty, such as conformal prediction, applied to one traffic stream or to network slices. What I did not find is a method that turns a forecast distribution of deadline-sensitive demand into per-cell budgets under one shared link constraint, and tests it fairly against strong reactive and point-forecast controllers. The full list with DOIs is in the literature review file.</a:t>
+              <a:t>Three groups of work. First, the standards and surveys that define the fronthaul model. Second, work that forecasts traffic and then plans capacity, mostly with neural networks and a single predicted number, with uncertainty handled by a fixed safety margin if at all. Third, work on forecasts with uncertainty, such as conformal prediction, applied to one traffic stream or to network slices. What I did not find is a method that turns a forecast distribution of deadline-sensitive demand into per-cell budgets under one shared link constraint, and tests it fairly against strong reactive and point-forecast controllers. The full list with DOIs is in the literature review file.</a:t>
             </a:r>
           </a:p>
         </p:txBody>
@@ -5363,7 +5363,7 @@
               </a:defRPr>
             </a:pPr>
             <a:r>
-              <a:t>B.Tech. Project — mid-term evaluation</a:t>
+              <a:t>B.Tech. Project, mid-term evaluation</a:t>
             </a:r>
           </a:p>
         </p:txBody>
@@ -5564,7 +5564,7 @@
               </a:defRPr>
             </a:pPr>
             <a:r>
-              <a:t>Part B — proposed</a:t>
+              <a:t>Part B: proposed</a:t>
             </a:r>
           </a:p>
         </p:txBody>
@@ -5757,7 +5757,7 @@
               </a:defRPr>
             </a:pPr>
             <a:r>
-              <a:t>• Optional: an online calibration step (ACI) that shifts a cell's quantile level after misses — tested as an ablation</a:t>
+              <a:t>• Optional: an online calibration step (ACI) that shifts a cell's quantile level after misses; tested as an ablation</a:t>
             </a:r>
           </a:p>
           <a:p>
@@ -6322,7 +6322,7 @@
               </a:defRPr>
             </a:pPr>
             <a:r>
-              <a:t>Part B — experiments</a:t>
+              <a:t>Part B: experiments</a:t>
             </a:r>
           </a:p>
         </p:txBody>
@@ -6840,7 +6840,7 @@
                         <a:defRPr sz="1200"/>
                       </a:pPr>
                       <a:r>
-                        <a:t>bursts 1.5× stronger and 1.5× longer, heavier tail — never seen in training or tuning</a:t>
+                        <a:t>bursts 1.5× stronger and 1.5× longer, heavier tail; never seen in training or tuning</a:t>
                       </a:r>
                     </a:p>
                   </a:txBody>
@@ -6922,7 +6922,7 @@
               </a:defRPr>
             </a:pPr>
             <a:r>
-              <a:t>• Seeds: training 1000-1015 (loads 0.5-0.95) | validation 2000-2003 | test 3000-3019 — no overlap</a:t>
+              <a:t>• Seeds: training 1000-1015 (loads 0.5-0.95) | validation 2000-2003 | test 3000-3019; no overlap</a:t>
             </a:r>
           </a:p>
           <a:p>
@@ -7098,7 +7098,7 @@
               </a:defRPr>
             </a:pPr>
             <a:r>
-              <a:t>Part B — results</a:t>
+              <a:t>Part B: results</a:t>
             </a:r>
           </a:p>
         </p:txBody>
@@ -7255,7 +7255,7 @@
               </a:defRPr>
             </a:pPr>
             <a:r>
-              <a:t>– vs MaxWeight: −31 % (high); vs fixed global quantile: −32 % (high) — per-cell levels beat one global level</a:t>
+              <a:t>– vs MaxWeight: −31 % (high); vs fixed global quantile: −32 % (high); per-cell levels beat one global level</a:t>
             </a:r>
           </a:p>
           <a:p>
@@ -7416,7 +7416,7 @@
               </a:defRPr>
             </a:pPr>
             <a:r>
-              <a:t>Part B — results</a:t>
+              <a:t>Part B: results</a:t>
             </a:r>
           </a:p>
         </p:txBody>
@@ -7719,7 +7719,7 @@
               </a:defRPr>
             </a:pPr>
             <a:r>
-              <a:t>Part B — results</a:t>
+              <a:t>Part B: results</a:t>
             </a:r>
           </a:p>
         </p:txBody>
@@ -7816,7 +7816,7 @@
               </a:defRPr>
             </a:pPr>
             <a:r>
-              <a:t>• Reactive proportional: low-latency loss 14.7% vs 3.4% for proposed — controllers that ignore deadlines sacrifice the low-latency cells</a:t>
+              <a:t>• Reactive proportional: low-latency loss 14.7% vs 3.4% for proposed; controllers that ignore deadlines sacrifice the low-latency cells</a:t>
             </a:r>
           </a:p>
           <a:p>
@@ -8164,7 +8164,7 @@
               </a:defRPr>
             </a:pPr>
             <a:r>
-              <a:t>• At ~1.0 load no allocation rule helps — compress more (Part A) or add capacity</a:t>
+              <a:t>• At ~1.0 load no allocation rule helps; compress more (Part A) or add capacity</a:t>
             </a:r>
           </a:p>
           <a:p>
@@ -8310,7 +8310,7 @@
               </a:defRPr>
             </a:pPr>
             <a:r>
-              <a:t>Part B — ablation</a:t>
+              <a:t>Part B: ablation</a:t>
             </a:r>
           </a:p>
         </p:txBody>
@@ -8725,7 +8725,7 @@
               </a:defRPr>
             </a:pPr>
             <a:r>
-              <a:t>• Part B: synthetic traffic only — no real radio-unit traces, so no real-world validation is claimed</a:t>
+              <a:t>• Part B: synthetic traffic only; no real radio-unit traces, so no real-world validation is claimed</a:t>
             </a:r>
           </a:p>
           <a:p>
@@ -8755,7 +8755,7 @@
               </a:defRPr>
             </a:pPr>
             <a:r>
-              <a:t>• Online calibration (ACI) did not help — reported as a negative result; the simple-quantile variant is the current fallback</a:t>
+              <a:t>• Online calibration (ACI) did not help; reported as a negative result; the simple-quantile variant is the current fallback</a:t>
             </a:r>
           </a:p>
           <a:p>
@@ -8815,7 +8815,7 @@
               </a:defRPr>
             </a:pPr>
             <a:r>
-              <a:t>• Proofs cover feasibility, equal weighted risk, backlog-first and bounded loss under forecast miscalibration — no stability or closed-loop optimality claims</a:t>
+              <a:t>• Proofs cover feasibility, equal weighted risk, backlog-first and bounded loss under forecast miscalibration; no stability or closed-loop optimality claims</a:t>
             </a:r>
           </a:p>
         </p:txBody>
@@ -9073,7 +9073,7 @@
               </a:defRPr>
             </a:pPr>
             <a:r>
-              <a:t>• Part A: compression study (BFP, SVD, RAS-BFP, CSEE, ACAFS) — 4 figure suites + report</a:t>
+              <a:t>• Part A: compression study (BFP, SVD, RAS-BFP, CSEE, ACAFS): 4 figure suites + report</a:t>
             </a:r>
           </a:p>
           <a:p>
@@ -9088,7 +9088,7 @@
               </a:defRPr>
             </a:pPr>
             <a:r>
-              <a:t>• Part A: matrix-inversion benchmark (LU, QR, SVD, Newton-Schulz, learned inverters; n = 10/100/500) — CSV + figure</a:t>
+              <a:t>• Part A: matrix-inversion benchmark (LU, QR, SVD, Newton-Schulz, learned inverters; n = 10/100/500): CSV + figure</a:t>
             </a:r>
           </a:p>
           <a:p>
@@ -9411,7 +9411,7 @@
               </a:defRPr>
             </a:pPr>
             <a:r>
-              <a:t>Backup: one trace — budgets vs demand of a low-latency cell</a:t>
+              <a:t>Backup: one trace, budgets vs demand of a low-latency cell</a:t>
             </a:r>
           </a:p>
         </p:txBody>
@@ -9754,7 +9754,7 @@
               </a:defRPr>
             </a:pPr>
             <a:r>
-              <a:t>• Several cells share one link that is smaller than their total peak — on purpose (statistical multiplexing)</a:t>
+              <a:t>• Several cells share one link that is smaller than their total peak, on purpose (statistical multiplexing)</a:t>
             </a:r>
           </a:p>
           <a:p>
@@ -9814,7 +9814,7 @@
               </a:defRPr>
             </a:pPr>
             <a:r>
-              <a:t>– A. Make the data smaller — compression (matrix decomposition, quantisation)</a:t>
+              <a:t>– A. Make the data smaller: compression (matrix decomposition, quantisation)</a:t>
             </a:r>
           </a:p>
           <a:p>
@@ -9829,7 +9829,7 @@
               </a:defRPr>
             </a:pPr>
             <a:r>
-              <a:t>– B. Share the link well — decide every few milliseconds how much each cell may send</a:t>
+              <a:t>– B. Share the link well: decide every few milliseconds how much each cell may send</a:t>
             </a:r>
           </a:p>
         </p:txBody>
@@ -13599,7 +13599,7 @@
               </a:defRPr>
             </a:pPr>
             <a:r>
-              <a:t>• Property 1 (feasibility): budgets always respect the caps and Σ r_i ≤ link — checked by test_kkt_allocation_properties</a:t>
+              <a:t>• Property 1 (feasibility): budgets always respect the caps and Σ r_i ≤ link; checked by test_kkt_allocation_properties</a:t>
             </a:r>
           </a:p>
           <a:p>
@@ -14112,7 +14112,7 @@
               </a:defRPr>
             </a:pPr>
             <a:r>
-              <a:t>• O-RAN WG4, Control, User and Synchronization Plane Specification (O-RAN.WG4.CUS.0) [standard] — 7-2x, BFP compression (Annex A.1), T2a windows. 3GPP TR 38.801 [standard]; 3GPP TR 38.901 (TDL-A channel) [standard]; IEEE 802.1CM-2018 [standard].</a:t>
+              <a:t>• O-RAN WG4, Control, User and Synchronization Plane Specification (O-RAN.WG4.CUS.0) [standard]: 7-2x, BFP compression (Annex A.1), T2a windows. 3GPP TR 38.801 [standard]; 3GPP TR 38.901 (TDL-A channel) [standard]; IEEE 802.1CM-2018 [standard].</a:t>
             </a:r>
           </a:p>
           <a:p>
@@ -14467,7 +14467,7 @@
               </a:defRPr>
             </a:pPr>
             <a:r>
-              <a:t>Part A — make the data smaller (earlier work)</a:t>
+              <a:t>Part A: make the data smaller (earlier work)</a:t>
             </a:r>
           </a:p>
         </p:txBody>
@@ -14634,7 +14634,7 @@
               </a:defRPr>
             </a:pPr>
             <a:r>
-              <a:t>Part B — share the link well (this term)</a:t>
+              <a:t>Part B: share the link well (this term)</a:t>
             </a:r>
           </a:p>
         </p:txBody>
@@ -14747,7 +14747,7 @@
               </a:defRPr>
             </a:pPr>
             <a:r>
-              <a:t>• Output: raw metrics, figures, this deck — all regenerated by scripts</a:t>
+              <a:t>• Output: raw metrics, figures, this deck; all regenerated by scripts</a:t>
             </a:r>
           </a:p>
         </p:txBody>
@@ -16232,7 +16232,7 @@
               </a:defRPr>
             </a:pPr>
             <a:r>
-              <a:t>• Lesson for Part B: predictable compute time matters as much as average speed — the allocation rule below is a closed form plus one scalar search</a:t>
+              <a:t>• Lesson for Part B: predictable compute time matters as much as average speed; the allocation rule below is a closed form plus one scalar search</a:t>
             </a:r>
           </a:p>
         </p:txBody>
@@ -16363,7 +16363,7 @@
               </a:defRPr>
             </a:pPr>
             <a:r>
-              <a:t>Part B — model</a:t>
+              <a:t>Part B: model</a:t>
             </a:r>
           </a:p>
         </p:txBody>
@@ -16466,7 +16466,7 @@
               </a:defRPr>
             </a:pPr>
             <a:r>
-              <a:t>• Fronthaul bits = user bits ÷ spectral efficiency × bits per resource block — so fronthaul load ≠ user traffic</a:t>
+              <a:t>• Fronthaul bits = user bits ÷ spectral efficiency × bits per resource block, so fronthaul load ≠ user traffic</a:t>
             </a:r>
           </a:p>
           <a:p>
@@ -17091,7 +17091,7 @@
               </a:defRPr>
             </a:pPr>
             <a:r>
-              <a:t>Part B — literature</a:t>
+              <a:t>Part B: literature</a:t>
             </a:r>
           </a:p>
         </p:txBody>
@@ -17209,7 +17209,7 @@
               </a:defRPr>
             </a:pPr>
             <a:r>
-              <a:t>– Lagén et al., IEEE Commun. Mag. 2022: several 7-2x cells share one link, compression is adjusted per slot — reactive, no forecast</a:t>
+              <a:t>– Lagén et al., IEEE Commun. Mag. 2022: several 7-2x cells share one link, compression is adjusted per slot; reactive, no forecast</a:t>
             </a:r>
           </a:p>
           <a:p>
@@ -17460,7 +17460,7 @@
               </a:defRPr>
             </a:pPr>
             <a:r>
-              <a:t>Part B — formulation</a:t>
+              <a:t>Part B: formulation</a:t>
             </a:r>
           </a:p>
         </p:txBody>
@@ -17608,7 +17608,7 @@
               </a:defRPr>
             </a:pPr>
             <a:r>
-              <a:t>– r* = max over time windows of (bits in window) / (window length + D)   — a standard network-calculus bound</a:t>
+              <a:t>– r* = max over time windows of (bits in window) / (window length + D), a standard network-calculus bound</a:t>
             </a:r>
           </a:p>
           <a:p>
@@ -17784,7 +17784,7 @@
               </a:defRPr>
             </a:pPr>
             <a:r>
-              <a:t>Part B — baselines</a:t>
+              <a:t>Part B: baselines</a:t>
             </a:r>
           </a:p>
         </p:txBody>
@@ -18009,7 +18009,7 @@
                         <a:defRPr sz="1100"/>
                       </a:pPr>
                       <a:r>
-                        <a:t>—</a:t>
+                        <a:t>-</a:t>
                       </a:r>
                     </a:p>
                   </a:txBody>
@@ -18477,7 +18477,7 @@
                         <a:defRPr sz="1100"/>
                       </a:pPr>
                       <a:r>
-                        <a:t>—</a:t>
+                        <a:t>-</a:t>
                       </a:r>
                     </a:p>
                   </a:txBody>
@@ -18555,7 +18555,7 @@
               </a:defRPr>
             </a:pPr>
             <a:r>
-              <a:t>– Finding: every safety margin above 0 was worse. Inflating a single number hurts when the shortage is split proportionally — the cells that over-claim get more</a:t>
+              <a:t>– Finding: every safety margin above 0 was worse. Inflating a single number hurts when the shortage is split proportionally: the cells that over-claim get more</a:t>
             </a:r>
           </a:p>
           <a:p>

</xml_diff>